<commit_message>
Edits. Checkpoint. Revert here if normalization fails.
</commit_message>
<xml_diff>
--- a/analysis/submitted_analyses/RaDDM_IndividualEstimates_E+C.pptx
+++ b/analysis/submitted_analyses/RaDDM_IndividualEstimates_E+C.pptx
@@ -2,12 +2,12 @@
 <file path=ppt/presentation.xml><?xml version="1.0" encoding="utf-8"?>
 <p:presentation xmlns:a="http://schemas.openxmlformats.org/drawingml/2006/main" xmlns:r="http://schemas.openxmlformats.org/officeDocument/2006/relationships" xmlns:p="http://schemas.openxmlformats.org/presentationml/2006/main" saveSubsetFonts="1" autoCompressPictures="0">
   <p:sldMasterIdLst>
-    <p:sldMasterId id="2147483876" r:id="rId1"/>
+    <p:sldMasterId id="2147483888" r:id="rId1"/>
   </p:sldMasterIdLst>
   <p:sldIdLst>
     <p:sldId id="257" r:id="rId2"/>
   </p:sldIdLst>
-  <p:sldSz cx="11595100" cy="8229600"/>
+  <p:sldSz cx="9875838" cy="8229600"/>
   <p:notesSz cx="6858000" cy="9144000"/>
   <p:defaultTextStyle>
     <a:defPPr>
@@ -141,15 +141,15 @@
         </p:nvSpPr>
         <p:spPr>
           <a:xfrm>
-            <a:off x="869633" y="1346836"/>
-            <a:ext cx="9855835" cy="2865120"/>
+            <a:off x="740688" y="1346836"/>
+            <a:ext cx="8394462" cy="2865120"/>
           </a:xfrm>
         </p:spPr>
         <p:txBody>
           <a:bodyPr anchor="b"/>
           <a:lstStyle>
             <a:lvl1pPr algn="ctr">
-              <a:defRPr sz="7200"/>
+              <a:defRPr sz="6480"/>
             </a:lvl1pPr>
           </a:lstStyle>
           <a:p>
@@ -173,8 +173,8 @@
         </p:nvSpPr>
         <p:spPr>
           <a:xfrm>
-            <a:off x="1449388" y="4322446"/>
-            <a:ext cx="8696325" cy="1986914"/>
+            <a:off x="1234480" y="4322446"/>
+            <a:ext cx="7406879" cy="1986914"/>
           </a:xfrm>
         </p:spPr>
         <p:txBody>
@@ -182,39 +182,39 @@
           <a:lstStyle>
             <a:lvl1pPr marL="0" indent="0" algn="ctr">
               <a:buNone/>
-              <a:defRPr sz="2880"/>
+              <a:defRPr sz="2592"/>
             </a:lvl1pPr>
-            <a:lvl2pPr marL="548640" indent="0" algn="ctr">
-              <a:buNone/>
-              <a:defRPr sz="2400"/>
+            <a:lvl2pPr marL="493776" indent="0" algn="ctr">
+              <a:buNone/>
+              <a:defRPr sz="2160"/>
             </a:lvl2pPr>
-            <a:lvl3pPr marL="1097280" indent="0" algn="ctr">
-              <a:buNone/>
-              <a:defRPr sz="2160"/>
+            <a:lvl3pPr marL="987552" indent="0" algn="ctr">
+              <a:buNone/>
+              <a:defRPr sz="1944"/>
             </a:lvl3pPr>
-            <a:lvl4pPr marL="1645920" indent="0" algn="ctr">
-              <a:buNone/>
-              <a:defRPr sz="1920"/>
+            <a:lvl4pPr marL="1481328" indent="0" algn="ctr">
+              <a:buNone/>
+              <a:defRPr sz="1728"/>
             </a:lvl4pPr>
-            <a:lvl5pPr marL="2194560" indent="0" algn="ctr">
-              <a:buNone/>
-              <a:defRPr sz="1920"/>
+            <a:lvl5pPr marL="1975104" indent="0" algn="ctr">
+              <a:buNone/>
+              <a:defRPr sz="1728"/>
             </a:lvl5pPr>
-            <a:lvl6pPr marL="2743200" indent="0" algn="ctr">
-              <a:buNone/>
-              <a:defRPr sz="1920"/>
+            <a:lvl6pPr marL="2468880" indent="0" algn="ctr">
+              <a:buNone/>
+              <a:defRPr sz="1728"/>
             </a:lvl6pPr>
-            <a:lvl7pPr marL="3291840" indent="0" algn="ctr">
-              <a:buNone/>
-              <a:defRPr sz="1920"/>
+            <a:lvl7pPr marL="2962656" indent="0" algn="ctr">
+              <a:buNone/>
+              <a:defRPr sz="1728"/>
             </a:lvl7pPr>
-            <a:lvl8pPr marL="3840480" indent="0" algn="ctr">
-              <a:buNone/>
-              <a:defRPr sz="1920"/>
+            <a:lvl8pPr marL="3456432" indent="0" algn="ctr">
+              <a:buNone/>
+              <a:defRPr sz="1728"/>
             </a:lvl8pPr>
-            <a:lvl9pPr marL="4389120" indent="0" algn="ctr">
-              <a:buNone/>
-              <a:defRPr sz="1920"/>
+            <a:lvl9pPr marL="3950208" indent="0" algn="ctr">
+              <a:buNone/>
+              <a:defRPr sz="1728"/>
             </a:lvl9pPr>
           </a:lstStyle>
           <a:p>
@@ -243,7 +243,7 @@
           <a:p>
             <a:fld id="{CFC60B5F-2253-DF41-8690-61B53F1555CE}" type="datetimeFigureOut">
               <a:rPr lang="en-US" smtClean="0"/>
-              <a:t>6/18/24</a:t>
+              <a:t>7/1/24</a:t>
             </a:fld>
             <a:endParaRPr lang="en-US"/>
           </a:p>
@@ -294,7 +294,7 @@
     </p:spTree>
     <p:extLst>
       <p:ext uri="{BB962C8B-B14F-4D97-AF65-F5344CB8AC3E}">
-        <p14:creationId xmlns:p14="http://schemas.microsoft.com/office/powerpoint/2010/main" val="276263479"/>
+        <p14:creationId xmlns:p14="http://schemas.microsoft.com/office/powerpoint/2010/main" val="527416198"/>
       </p:ext>
     </p:extLst>
   </p:cSld>
@@ -413,7 +413,7 @@
           <a:p>
             <a:fld id="{CFC60B5F-2253-DF41-8690-61B53F1555CE}" type="datetimeFigureOut">
               <a:rPr lang="en-US" smtClean="0"/>
-              <a:t>6/18/24</a:t>
+              <a:t>7/1/24</a:t>
             </a:fld>
             <a:endParaRPr lang="en-US"/>
           </a:p>
@@ -464,7 +464,7 @@
     </p:spTree>
     <p:extLst>
       <p:ext uri="{BB962C8B-B14F-4D97-AF65-F5344CB8AC3E}">
-        <p14:creationId xmlns:p14="http://schemas.microsoft.com/office/powerpoint/2010/main" val="808143864"/>
+        <p14:creationId xmlns:p14="http://schemas.microsoft.com/office/powerpoint/2010/main" val="3976850423"/>
       </p:ext>
     </p:extLst>
   </p:cSld>
@@ -503,8 +503,8 @@
         </p:nvSpPr>
         <p:spPr>
           <a:xfrm>
-            <a:off x="8297744" y="438150"/>
-            <a:ext cx="2500193" cy="6974206"/>
+            <a:off x="7067397" y="438150"/>
+            <a:ext cx="2129478" cy="6974206"/>
           </a:xfrm>
         </p:spPr>
         <p:txBody>
@@ -531,8 +531,8 @@
         </p:nvSpPr>
         <p:spPr>
           <a:xfrm>
-            <a:off x="797164" y="438150"/>
-            <a:ext cx="7355642" cy="6974206"/>
+            <a:off x="678964" y="438150"/>
+            <a:ext cx="6264985" cy="6974206"/>
           </a:xfrm>
         </p:spPr>
         <p:txBody>
@@ -593,7 +593,7 @@
           <a:p>
             <a:fld id="{CFC60B5F-2253-DF41-8690-61B53F1555CE}" type="datetimeFigureOut">
               <a:rPr lang="en-US" smtClean="0"/>
-              <a:t>6/18/24</a:t>
+              <a:t>7/1/24</a:t>
             </a:fld>
             <a:endParaRPr lang="en-US"/>
           </a:p>
@@ -644,7 +644,7 @@
     </p:spTree>
     <p:extLst>
       <p:ext uri="{BB962C8B-B14F-4D97-AF65-F5344CB8AC3E}">
-        <p14:creationId xmlns:p14="http://schemas.microsoft.com/office/powerpoint/2010/main" val="3513549470"/>
+        <p14:creationId xmlns:p14="http://schemas.microsoft.com/office/powerpoint/2010/main" val="1413490495"/>
       </p:ext>
     </p:extLst>
   </p:cSld>
@@ -763,7 +763,7 @@
           <a:p>
             <a:fld id="{CFC60B5F-2253-DF41-8690-61B53F1555CE}" type="datetimeFigureOut">
               <a:rPr lang="en-US" smtClean="0"/>
-              <a:t>6/18/24</a:t>
+              <a:t>7/1/24</a:t>
             </a:fld>
             <a:endParaRPr lang="en-US"/>
           </a:p>
@@ -814,7 +814,7 @@
     </p:spTree>
     <p:extLst>
       <p:ext uri="{BB962C8B-B14F-4D97-AF65-F5344CB8AC3E}">
-        <p14:creationId xmlns:p14="http://schemas.microsoft.com/office/powerpoint/2010/main" val="2671391109"/>
+        <p14:creationId xmlns:p14="http://schemas.microsoft.com/office/powerpoint/2010/main" val="3425667778"/>
       </p:ext>
     </p:extLst>
   </p:cSld>
@@ -853,15 +853,15 @@
         </p:nvSpPr>
         <p:spPr>
           <a:xfrm>
-            <a:off x="791125" y="2051688"/>
-            <a:ext cx="10000774" cy="3423284"/>
+            <a:off x="673821" y="2051688"/>
+            <a:ext cx="8517910" cy="3423284"/>
           </a:xfrm>
         </p:spPr>
         <p:txBody>
           <a:bodyPr anchor="b"/>
           <a:lstStyle>
             <a:lvl1pPr>
-              <a:defRPr sz="7200"/>
+              <a:defRPr sz="6480"/>
             </a:lvl1pPr>
           </a:lstStyle>
           <a:p>
@@ -885,8 +885,8 @@
         </p:nvSpPr>
         <p:spPr>
           <a:xfrm>
-            <a:off x="791125" y="5507358"/>
-            <a:ext cx="10000774" cy="1800224"/>
+            <a:off x="673821" y="5507358"/>
+            <a:ext cx="8517910" cy="1800224"/>
           </a:xfrm>
         </p:spPr>
         <p:txBody>
@@ -894,15 +894,15 @@
           <a:lstStyle>
             <a:lvl1pPr marL="0" indent="0">
               <a:buNone/>
-              <a:defRPr sz="2880">
+              <a:defRPr sz="2592">
                 <a:solidFill>
                   <a:schemeClr val="tx1"/>
                 </a:solidFill>
               </a:defRPr>
             </a:lvl1pPr>
-            <a:lvl2pPr marL="548640" indent="0">
-              <a:buNone/>
-              <a:defRPr sz="2400">
+            <a:lvl2pPr marL="493776" indent="0">
+              <a:buNone/>
+              <a:defRPr sz="2160">
                 <a:solidFill>
                   <a:schemeClr val="tx1">
                     <a:tint val="75000"/>
@@ -910,9 +910,9 @@
                 </a:solidFill>
               </a:defRPr>
             </a:lvl2pPr>
-            <a:lvl3pPr marL="1097280" indent="0">
-              <a:buNone/>
-              <a:defRPr sz="2160">
+            <a:lvl3pPr marL="987552" indent="0">
+              <a:buNone/>
+              <a:defRPr sz="1944">
                 <a:solidFill>
                   <a:schemeClr val="tx1">
                     <a:tint val="75000"/>
@@ -920,9 +920,9 @@
                 </a:solidFill>
               </a:defRPr>
             </a:lvl3pPr>
-            <a:lvl4pPr marL="1645920" indent="0">
-              <a:buNone/>
-              <a:defRPr sz="1920">
+            <a:lvl4pPr marL="1481328" indent="0">
+              <a:buNone/>
+              <a:defRPr sz="1728">
                 <a:solidFill>
                   <a:schemeClr val="tx1">
                     <a:tint val="75000"/>
@@ -930,9 +930,9 @@
                 </a:solidFill>
               </a:defRPr>
             </a:lvl4pPr>
-            <a:lvl5pPr marL="2194560" indent="0">
-              <a:buNone/>
-              <a:defRPr sz="1920">
+            <a:lvl5pPr marL="1975104" indent="0">
+              <a:buNone/>
+              <a:defRPr sz="1728">
                 <a:solidFill>
                   <a:schemeClr val="tx1">
                     <a:tint val="75000"/>
@@ -940,9 +940,9 @@
                 </a:solidFill>
               </a:defRPr>
             </a:lvl5pPr>
-            <a:lvl6pPr marL="2743200" indent="0">
-              <a:buNone/>
-              <a:defRPr sz="1920">
+            <a:lvl6pPr marL="2468880" indent="0">
+              <a:buNone/>
+              <a:defRPr sz="1728">
                 <a:solidFill>
                   <a:schemeClr val="tx1">
                     <a:tint val="75000"/>
@@ -950,9 +950,9 @@
                 </a:solidFill>
               </a:defRPr>
             </a:lvl6pPr>
-            <a:lvl7pPr marL="3291840" indent="0">
-              <a:buNone/>
-              <a:defRPr sz="1920">
+            <a:lvl7pPr marL="2962656" indent="0">
+              <a:buNone/>
+              <a:defRPr sz="1728">
                 <a:solidFill>
                   <a:schemeClr val="tx1">
                     <a:tint val="75000"/>
@@ -960,9 +960,9 @@
                 </a:solidFill>
               </a:defRPr>
             </a:lvl7pPr>
-            <a:lvl8pPr marL="3840480" indent="0">
-              <a:buNone/>
-              <a:defRPr sz="1920">
+            <a:lvl8pPr marL="3456432" indent="0">
+              <a:buNone/>
+              <a:defRPr sz="1728">
                 <a:solidFill>
                   <a:schemeClr val="tx1">
                     <a:tint val="75000"/>
@@ -970,9 +970,9 @@
                 </a:solidFill>
               </a:defRPr>
             </a:lvl8pPr>
-            <a:lvl9pPr marL="4389120" indent="0">
-              <a:buNone/>
-              <a:defRPr sz="1920">
+            <a:lvl9pPr marL="3950208" indent="0">
+              <a:buNone/>
+              <a:defRPr sz="1728">
                 <a:solidFill>
                   <a:schemeClr val="tx1">
                     <a:tint val="75000"/>
@@ -1007,7 +1007,7 @@
           <a:p>
             <a:fld id="{CFC60B5F-2253-DF41-8690-61B53F1555CE}" type="datetimeFigureOut">
               <a:rPr lang="en-US" smtClean="0"/>
-              <a:t>6/18/24</a:t>
+              <a:t>7/1/24</a:t>
             </a:fld>
             <a:endParaRPr lang="en-US"/>
           </a:p>
@@ -1058,7 +1058,7 @@
     </p:spTree>
     <p:extLst>
       <p:ext uri="{BB962C8B-B14F-4D97-AF65-F5344CB8AC3E}">
-        <p14:creationId xmlns:p14="http://schemas.microsoft.com/office/powerpoint/2010/main" val="1400451074"/>
+        <p14:creationId xmlns:p14="http://schemas.microsoft.com/office/powerpoint/2010/main" val="2134386275"/>
       </p:ext>
     </p:extLst>
   </p:cSld>
@@ -1120,8 +1120,8 @@
         </p:nvSpPr>
         <p:spPr>
           <a:xfrm>
-            <a:off x="797163" y="2190750"/>
-            <a:ext cx="4927918" cy="5221606"/>
+            <a:off x="678964" y="2190750"/>
+            <a:ext cx="4197231" cy="5221606"/>
           </a:xfrm>
         </p:spPr>
         <p:txBody>
@@ -1177,8 +1177,8 @@
         </p:nvSpPr>
         <p:spPr>
           <a:xfrm>
-            <a:off x="5870019" y="2190750"/>
-            <a:ext cx="4927918" cy="5221606"/>
+            <a:off x="4999643" y="2190750"/>
+            <a:ext cx="4197231" cy="5221606"/>
           </a:xfrm>
         </p:spPr>
         <p:txBody>
@@ -1239,7 +1239,7 @@
           <a:p>
             <a:fld id="{CFC60B5F-2253-DF41-8690-61B53F1555CE}" type="datetimeFigureOut">
               <a:rPr lang="en-US" smtClean="0"/>
-              <a:t>6/18/24</a:t>
+              <a:t>7/1/24</a:t>
             </a:fld>
             <a:endParaRPr lang="en-US"/>
           </a:p>
@@ -1290,7 +1290,7 @@
     </p:spTree>
     <p:extLst>
       <p:ext uri="{BB962C8B-B14F-4D97-AF65-F5344CB8AC3E}">
-        <p14:creationId xmlns:p14="http://schemas.microsoft.com/office/powerpoint/2010/main" val="2961123526"/>
+        <p14:creationId xmlns:p14="http://schemas.microsoft.com/office/powerpoint/2010/main" val="2635576009"/>
       </p:ext>
     </p:extLst>
   </p:cSld>
@@ -1329,8 +1329,8 @@
         </p:nvSpPr>
         <p:spPr>
           <a:xfrm>
-            <a:off x="798673" y="438152"/>
-            <a:ext cx="10000774" cy="1590676"/>
+            <a:off x="680250" y="438152"/>
+            <a:ext cx="8517910" cy="1590676"/>
           </a:xfrm>
         </p:spPr>
         <p:txBody>
@@ -1357,8 +1357,8 @@
         </p:nvSpPr>
         <p:spPr>
           <a:xfrm>
-            <a:off x="798675" y="2017396"/>
-            <a:ext cx="4905270" cy="988694"/>
+            <a:off x="680251" y="2017396"/>
+            <a:ext cx="4177942" cy="988694"/>
           </a:xfrm>
         </p:spPr>
         <p:txBody>
@@ -1366,39 +1366,39 @@
           <a:lstStyle>
             <a:lvl1pPr marL="0" indent="0">
               <a:buNone/>
-              <a:defRPr sz="2880" b="1"/>
+              <a:defRPr sz="2592" b="1"/>
             </a:lvl1pPr>
-            <a:lvl2pPr marL="548640" indent="0">
-              <a:buNone/>
-              <a:defRPr sz="2400" b="1"/>
+            <a:lvl2pPr marL="493776" indent="0">
+              <a:buNone/>
+              <a:defRPr sz="2160" b="1"/>
             </a:lvl2pPr>
-            <a:lvl3pPr marL="1097280" indent="0">
-              <a:buNone/>
-              <a:defRPr sz="2160" b="1"/>
+            <a:lvl3pPr marL="987552" indent="0">
+              <a:buNone/>
+              <a:defRPr sz="1944" b="1"/>
             </a:lvl3pPr>
-            <a:lvl4pPr marL="1645920" indent="0">
-              <a:buNone/>
-              <a:defRPr sz="1920" b="1"/>
+            <a:lvl4pPr marL="1481328" indent="0">
+              <a:buNone/>
+              <a:defRPr sz="1728" b="1"/>
             </a:lvl4pPr>
-            <a:lvl5pPr marL="2194560" indent="0">
-              <a:buNone/>
-              <a:defRPr sz="1920" b="1"/>
+            <a:lvl5pPr marL="1975104" indent="0">
+              <a:buNone/>
+              <a:defRPr sz="1728" b="1"/>
             </a:lvl5pPr>
-            <a:lvl6pPr marL="2743200" indent="0">
-              <a:buNone/>
-              <a:defRPr sz="1920" b="1"/>
+            <a:lvl6pPr marL="2468880" indent="0">
+              <a:buNone/>
+              <a:defRPr sz="1728" b="1"/>
             </a:lvl6pPr>
-            <a:lvl7pPr marL="3291840" indent="0">
-              <a:buNone/>
-              <a:defRPr sz="1920" b="1"/>
+            <a:lvl7pPr marL="2962656" indent="0">
+              <a:buNone/>
+              <a:defRPr sz="1728" b="1"/>
             </a:lvl7pPr>
-            <a:lvl8pPr marL="3840480" indent="0">
-              <a:buNone/>
-              <a:defRPr sz="1920" b="1"/>
+            <a:lvl8pPr marL="3456432" indent="0">
+              <a:buNone/>
+              <a:defRPr sz="1728" b="1"/>
             </a:lvl8pPr>
-            <a:lvl9pPr marL="4389120" indent="0">
-              <a:buNone/>
-              <a:defRPr sz="1920" b="1"/>
+            <a:lvl9pPr marL="3950208" indent="0">
+              <a:buNone/>
+              <a:defRPr sz="1728" b="1"/>
             </a:lvl9pPr>
           </a:lstStyle>
           <a:p>
@@ -1422,8 +1422,8 @@
         </p:nvSpPr>
         <p:spPr>
           <a:xfrm>
-            <a:off x="798675" y="3006090"/>
-            <a:ext cx="4905270" cy="4421506"/>
+            <a:off x="680251" y="3006090"/>
+            <a:ext cx="4177942" cy="4421506"/>
           </a:xfrm>
         </p:spPr>
         <p:txBody>
@@ -1479,8 +1479,8 @@
         </p:nvSpPr>
         <p:spPr>
           <a:xfrm>
-            <a:off x="5870020" y="2017396"/>
-            <a:ext cx="4929428" cy="988694"/>
+            <a:off x="4999644" y="2017396"/>
+            <a:ext cx="4198517" cy="988694"/>
           </a:xfrm>
         </p:spPr>
         <p:txBody>
@@ -1488,39 +1488,39 @@
           <a:lstStyle>
             <a:lvl1pPr marL="0" indent="0">
               <a:buNone/>
-              <a:defRPr sz="2880" b="1"/>
+              <a:defRPr sz="2592" b="1"/>
             </a:lvl1pPr>
-            <a:lvl2pPr marL="548640" indent="0">
-              <a:buNone/>
-              <a:defRPr sz="2400" b="1"/>
+            <a:lvl2pPr marL="493776" indent="0">
+              <a:buNone/>
+              <a:defRPr sz="2160" b="1"/>
             </a:lvl2pPr>
-            <a:lvl3pPr marL="1097280" indent="0">
-              <a:buNone/>
-              <a:defRPr sz="2160" b="1"/>
+            <a:lvl3pPr marL="987552" indent="0">
+              <a:buNone/>
+              <a:defRPr sz="1944" b="1"/>
             </a:lvl3pPr>
-            <a:lvl4pPr marL="1645920" indent="0">
-              <a:buNone/>
-              <a:defRPr sz="1920" b="1"/>
+            <a:lvl4pPr marL="1481328" indent="0">
+              <a:buNone/>
+              <a:defRPr sz="1728" b="1"/>
             </a:lvl4pPr>
-            <a:lvl5pPr marL="2194560" indent="0">
-              <a:buNone/>
-              <a:defRPr sz="1920" b="1"/>
+            <a:lvl5pPr marL="1975104" indent="0">
+              <a:buNone/>
+              <a:defRPr sz="1728" b="1"/>
             </a:lvl5pPr>
-            <a:lvl6pPr marL="2743200" indent="0">
-              <a:buNone/>
-              <a:defRPr sz="1920" b="1"/>
+            <a:lvl6pPr marL="2468880" indent="0">
+              <a:buNone/>
+              <a:defRPr sz="1728" b="1"/>
             </a:lvl6pPr>
-            <a:lvl7pPr marL="3291840" indent="0">
-              <a:buNone/>
-              <a:defRPr sz="1920" b="1"/>
+            <a:lvl7pPr marL="2962656" indent="0">
+              <a:buNone/>
+              <a:defRPr sz="1728" b="1"/>
             </a:lvl7pPr>
-            <a:lvl8pPr marL="3840480" indent="0">
-              <a:buNone/>
-              <a:defRPr sz="1920" b="1"/>
+            <a:lvl8pPr marL="3456432" indent="0">
+              <a:buNone/>
+              <a:defRPr sz="1728" b="1"/>
             </a:lvl8pPr>
-            <a:lvl9pPr marL="4389120" indent="0">
-              <a:buNone/>
-              <a:defRPr sz="1920" b="1"/>
+            <a:lvl9pPr marL="3950208" indent="0">
+              <a:buNone/>
+              <a:defRPr sz="1728" b="1"/>
             </a:lvl9pPr>
           </a:lstStyle>
           <a:p>
@@ -1544,8 +1544,8 @@
         </p:nvSpPr>
         <p:spPr>
           <a:xfrm>
-            <a:off x="5870020" y="3006090"/>
-            <a:ext cx="4929428" cy="4421506"/>
+            <a:off x="4999644" y="3006090"/>
+            <a:ext cx="4198517" cy="4421506"/>
           </a:xfrm>
         </p:spPr>
         <p:txBody>
@@ -1606,7 +1606,7 @@
           <a:p>
             <a:fld id="{CFC60B5F-2253-DF41-8690-61B53F1555CE}" type="datetimeFigureOut">
               <a:rPr lang="en-US" smtClean="0"/>
-              <a:t>6/18/24</a:t>
+              <a:t>7/1/24</a:t>
             </a:fld>
             <a:endParaRPr lang="en-US"/>
           </a:p>
@@ -1657,7 +1657,7 @@
     </p:spTree>
     <p:extLst>
       <p:ext uri="{BB962C8B-B14F-4D97-AF65-F5344CB8AC3E}">
-        <p14:creationId xmlns:p14="http://schemas.microsoft.com/office/powerpoint/2010/main" val="3155373356"/>
+        <p14:creationId xmlns:p14="http://schemas.microsoft.com/office/powerpoint/2010/main" val="515065446"/>
       </p:ext>
     </p:extLst>
   </p:cSld>
@@ -1724,7 +1724,7 @@
           <a:p>
             <a:fld id="{CFC60B5F-2253-DF41-8690-61B53F1555CE}" type="datetimeFigureOut">
               <a:rPr lang="en-US" smtClean="0"/>
-              <a:t>6/18/24</a:t>
+              <a:t>7/1/24</a:t>
             </a:fld>
             <a:endParaRPr lang="en-US"/>
           </a:p>
@@ -1775,7 +1775,7 @@
     </p:spTree>
     <p:extLst>
       <p:ext uri="{BB962C8B-B14F-4D97-AF65-F5344CB8AC3E}">
-        <p14:creationId xmlns:p14="http://schemas.microsoft.com/office/powerpoint/2010/main" val="3393756895"/>
+        <p14:creationId xmlns:p14="http://schemas.microsoft.com/office/powerpoint/2010/main" val="890725943"/>
       </p:ext>
     </p:extLst>
   </p:cSld>
@@ -1819,7 +1819,7 @@
           <a:p>
             <a:fld id="{CFC60B5F-2253-DF41-8690-61B53F1555CE}" type="datetimeFigureOut">
               <a:rPr lang="en-US" smtClean="0"/>
-              <a:t>6/18/24</a:t>
+              <a:t>7/1/24</a:t>
             </a:fld>
             <a:endParaRPr lang="en-US"/>
           </a:p>
@@ -1870,7 +1870,7 @@
     </p:spTree>
     <p:extLst>
       <p:ext uri="{BB962C8B-B14F-4D97-AF65-F5344CB8AC3E}">
-        <p14:creationId xmlns:p14="http://schemas.microsoft.com/office/powerpoint/2010/main" val="3254488032"/>
+        <p14:creationId xmlns:p14="http://schemas.microsoft.com/office/powerpoint/2010/main" val="1747801016"/>
       </p:ext>
     </p:extLst>
   </p:cSld>
@@ -1909,15 +1909,15 @@
         </p:nvSpPr>
         <p:spPr>
           <a:xfrm>
-            <a:off x="798673" y="548640"/>
-            <a:ext cx="3739722" cy="1920240"/>
+            <a:off x="680250" y="548640"/>
+            <a:ext cx="3185215" cy="1920240"/>
           </a:xfrm>
         </p:spPr>
         <p:txBody>
           <a:bodyPr anchor="b"/>
           <a:lstStyle>
             <a:lvl1pPr>
-              <a:defRPr sz="3840"/>
+              <a:defRPr sz="3456"/>
             </a:lvl1pPr>
           </a:lstStyle>
           <a:p>
@@ -1941,39 +1941,39 @@
         </p:nvSpPr>
         <p:spPr>
           <a:xfrm>
-            <a:off x="4929428" y="1184912"/>
-            <a:ext cx="5870019" cy="5848350"/>
+            <a:off x="4198517" y="1184912"/>
+            <a:ext cx="4999643" cy="5848350"/>
           </a:xfrm>
         </p:spPr>
         <p:txBody>
           <a:bodyPr/>
           <a:lstStyle>
             <a:lvl1pPr>
-              <a:defRPr sz="3840"/>
+              <a:defRPr sz="3456"/>
             </a:lvl1pPr>
             <a:lvl2pPr>
-              <a:defRPr sz="3360"/>
+              <a:defRPr sz="3024"/>
             </a:lvl2pPr>
             <a:lvl3pPr>
-              <a:defRPr sz="2880"/>
+              <a:defRPr sz="2592"/>
             </a:lvl3pPr>
             <a:lvl4pPr>
-              <a:defRPr sz="2400"/>
+              <a:defRPr sz="2160"/>
             </a:lvl4pPr>
             <a:lvl5pPr>
-              <a:defRPr sz="2400"/>
+              <a:defRPr sz="2160"/>
             </a:lvl5pPr>
             <a:lvl6pPr>
-              <a:defRPr sz="2400"/>
+              <a:defRPr sz="2160"/>
             </a:lvl6pPr>
             <a:lvl7pPr>
-              <a:defRPr sz="2400"/>
+              <a:defRPr sz="2160"/>
             </a:lvl7pPr>
             <a:lvl8pPr>
-              <a:defRPr sz="2400"/>
+              <a:defRPr sz="2160"/>
             </a:lvl8pPr>
             <a:lvl9pPr>
-              <a:defRPr sz="2400"/>
+              <a:defRPr sz="2160"/>
             </a:lvl9pPr>
           </a:lstStyle>
           <a:p>
@@ -2026,8 +2026,8 @@
         </p:nvSpPr>
         <p:spPr>
           <a:xfrm>
-            <a:off x="798673" y="2468880"/>
-            <a:ext cx="3739722" cy="4573906"/>
+            <a:off x="680250" y="2468880"/>
+            <a:ext cx="3185215" cy="4573906"/>
           </a:xfrm>
         </p:spPr>
         <p:txBody>
@@ -2035,39 +2035,39 @@
           <a:lstStyle>
             <a:lvl1pPr marL="0" indent="0">
               <a:buNone/>
-              <a:defRPr sz="1920"/>
+              <a:defRPr sz="1728"/>
             </a:lvl1pPr>
-            <a:lvl2pPr marL="548640" indent="0">
-              <a:buNone/>
-              <a:defRPr sz="1680"/>
+            <a:lvl2pPr marL="493776" indent="0">
+              <a:buNone/>
+              <a:defRPr sz="1512"/>
             </a:lvl2pPr>
-            <a:lvl3pPr marL="1097280" indent="0">
-              <a:buNone/>
-              <a:defRPr sz="1440"/>
+            <a:lvl3pPr marL="987552" indent="0">
+              <a:buNone/>
+              <a:defRPr sz="1296"/>
             </a:lvl3pPr>
-            <a:lvl4pPr marL="1645920" indent="0">
-              <a:buNone/>
-              <a:defRPr sz="1200"/>
+            <a:lvl4pPr marL="1481328" indent="0">
+              <a:buNone/>
+              <a:defRPr sz="1080"/>
             </a:lvl4pPr>
-            <a:lvl5pPr marL="2194560" indent="0">
-              <a:buNone/>
-              <a:defRPr sz="1200"/>
+            <a:lvl5pPr marL="1975104" indent="0">
+              <a:buNone/>
+              <a:defRPr sz="1080"/>
             </a:lvl5pPr>
-            <a:lvl6pPr marL="2743200" indent="0">
-              <a:buNone/>
-              <a:defRPr sz="1200"/>
+            <a:lvl6pPr marL="2468880" indent="0">
+              <a:buNone/>
+              <a:defRPr sz="1080"/>
             </a:lvl6pPr>
-            <a:lvl7pPr marL="3291840" indent="0">
-              <a:buNone/>
-              <a:defRPr sz="1200"/>
+            <a:lvl7pPr marL="2962656" indent="0">
+              <a:buNone/>
+              <a:defRPr sz="1080"/>
             </a:lvl7pPr>
-            <a:lvl8pPr marL="3840480" indent="0">
-              <a:buNone/>
-              <a:defRPr sz="1200"/>
+            <a:lvl8pPr marL="3456432" indent="0">
+              <a:buNone/>
+              <a:defRPr sz="1080"/>
             </a:lvl8pPr>
-            <a:lvl9pPr marL="4389120" indent="0">
-              <a:buNone/>
-              <a:defRPr sz="1200"/>
+            <a:lvl9pPr marL="3950208" indent="0">
+              <a:buNone/>
+              <a:defRPr sz="1080"/>
             </a:lvl9pPr>
           </a:lstStyle>
           <a:p>
@@ -2096,7 +2096,7 @@
           <a:p>
             <a:fld id="{CFC60B5F-2253-DF41-8690-61B53F1555CE}" type="datetimeFigureOut">
               <a:rPr lang="en-US" smtClean="0"/>
-              <a:t>6/18/24</a:t>
+              <a:t>7/1/24</a:t>
             </a:fld>
             <a:endParaRPr lang="en-US"/>
           </a:p>
@@ -2147,7 +2147,7 @@
     </p:spTree>
     <p:extLst>
       <p:ext uri="{BB962C8B-B14F-4D97-AF65-F5344CB8AC3E}">
-        <p14:creationId xmlns:p14="http://schemas.microsoft.com/office/powerpoint/2010/main" val="1920383463"/>
+        <p14:creationId xmlns:p14="http://schemas.microsoft.com/office/powerpoint/2010/main" val="693986325"/>
       </p:ext>
     </p:extLst>
   </p:cSld>
@@ -2186,15 +2186,15 @@
         </p:nvSpPr>
         <p:spPr>
           <a:xfrm>
-            <a:off x="798673" y="548640"/>
-            <a:ext cx="3739722" cy="1920240"/>
+            <a:off x="680250" y="548640"/>
+            <a:ext cx="3185215" cy="1920240"/>
           </a:xfrm>
         </p:spPr>
         <p:txBody>
           <a:bodyPr anchor="b"/>
           <a:lstStyle>
             <a:lvl1pPr>
-              <a:defRPr sz="3840"/>
+              <a:defRPr sz="3456"/>
             </a:lvl1pPr>
           </a:lstStyle>
           <a:p>
@@ -2218,8 +2218,8 @@
         </p:nvSpPr>
         <p:spPr>
           <a:xfrm>
-            <a:off x="4929428" y="1184912"/>
-            <a:ext cx="5870019" cy="5848350"/>
+            <a:off x="4198517" y="1184912"/>
+            <a:ext cx="4999643" cy="5848350"/>
           </a:xfrm>
         </p:spPr>
         <p:txBody>
@@ -2227,39 +2227,39 @@
           <a:lstStyle>
             <a:lvl1pPr marL="0" indent="0">
               <a:buNone/>
-              <a:defRPr sz="3840"/>
+              <a:defRPr sz="3456"/>
             </a:lvl1pPr>
-            <a:lvl2pPr marL="548640" indent="0">
-              <a:buNone/>
-              <a:defRPr sz="3360"/>
+            <a:lvl2pPr marL="493776" indent="0">
+              <a:buNone/>
+              <a:defRPr sz="3024"/>
             </a:lvl2pPr>
-            <a:lvl3pPr marL="1097280" indent="0">
-              <a:buNone/>
-              <a:defRPr sz="2880"/>
+            <a:lvl3pPr marL="987552" indent="0">
+              <a:buNone/>
+              <a:defRPr sz="2592"/>
             </a:lvl3pPr>
-            <a:lvl4pPr marL="1645920" indent="0">
-              <a:buNone/>
-              <a:defRPr sz="2400"/>
+            <a:lvl4pPr marL="1481328" indent="0">
+              <a:buNone/>
+              <a:defRPr sz="2160"/>
             </a:lvl4pPr>
-            <a:lvl5pPr marL="2194560" indent="0">
-              <a:buNone/>
-              <a:defRPr sz="2400"/>
+            <a:lvl5pPr marL="1975104" indent="0">
+              <a:buNone/>
+              <a:defRPr sz="2160"/>
             </a:lvl5pPr>
-            <a:lvl6pPr marL="2743200" indent="0">
-              <a:buNone/>
-              <a:defRPr sz="2400"/>
+            <a:lvl6pPr marL="2468880" indent="0">
+              <a:buNone/>
+              <a:defRPr sz="2160"/>
             </a:lvl6pPr>
-            <a:lvl7pPr marL="3291840" indent="0">
-              <a:buNone/>
-              <a:defRPr sz="2400"/>
+            <a:lvl7pPr marL="2962656" indent="0">
+              <a:buNone/>
+              <a:defRPr sz="2160"/>
             </a:lvl7pPr>
-            <a:lvl8pPr marL="3840480" indent="0">
-              <a:buNone/>
-              <a:defRPr sz="2400"/>
+            <a:lvl8pPr marL="3456432" indent="0">
+              <a:buNone/>
+              <a:defRPr sz="2160"/>
             </a:lvl8pPr>
-            <a:lvl9pPr marL="4389120" indent="0">
-              <a:buNone/>
-              <a:defRPr sz="2400"/>
+            <a:lvl9pPr marL="3950208" indent="0">
+              <a:buNone/>
+              <a:defRPr sz="2160"/>
             </a:lvl9pPr>
           </a:lstStyle>
           <a:p>
@@ -2283,8 +2283,8 @@
         </p:nvSpPr>
         <p:spPr>
           <a:xfrm>
-            <a:off x="798673" y="2468880"/>
-            <a:ext cx="3739722" cy="4573906"/>
+            <a:off x="680250" y="2468880"/>
+            <a:ext cx="3185215" cy="4573906"/>
           </a:xfrm>
         </p:spPr>
         <p:txBody>
@@ -2292,39 +2292,39 @@
           <a:lstStyle>
             <a:lvl1pPr marL="0" indent="0">
               <a:buNone/>
-              <a:defRPr sz="1920"/>
+              <a:defRPr sz="1728"/>
             </a:lvl1pPr>
-            <a:lvl2pPr marL="548640" indent="0">
-              <a:buNone/>
-              <a:defRPr sz="1680"/>
+            <a:lvl2pPr marL="493776" indent="0">
+              <a:buNone/>
+              <a:defRPr sz="1512"/>
             </a:lvl2pPr>
-            <a:lvl3pPr marL="1097280" indent="0">
-              <a:buNone/>
-              <a:defRPr sz="1440"/>
+            <a:lvl3pPr marL="987552" indent="0">
+              <a:buNone/>
+              <a:defRPr sz="1296"/>
             </a:lvl3pPr>
-            <a:lvl4pPr marL="1645920" indent="0">
-              <a:buNone/>
-              <a:defRPr sz="1200"/>
+            <a:lvl4pPr marL="1481328" indent="0">
+              <a:buNone/>
+              <a:defRPr sz="1080"/>
             </a:lvl4pPr>
-            <a:lvl5pPr marL="2194560" indent="0">
-              <a:buNone/>
-              <a:defRPr sz="1200"/>
+            <a:lvl5pPr marL="1975104" indent="0">
+              <a:buNone/>
+              <a:defRPr sz="1080"/>
             </a:lvl5pPr>
-            <a:lvl6pPr marL="2743200" indent="0">
-              <a:buNone/>
-              <a:defRPr sz="1200"/>
+            <a:lvl6pPr marL="2468880" indent="0">
+              <a:buNone/>
+              <a:defRPr sz="1080"/>
             </a:lvl6pPr>
-            <a:lvl7pPr marL="3291840" indent="0">
-              <a:buNone/>
-              <a:defRPr sz="1200"/>
+            <a:lvl7pPr marL="2962656" indent="0">
+              <a:buNone/>
+              <a:defRPr sz="1080"/>
             </a:lvl7pPr>
-            <a:lvl8pPr marL="3840480" indent="0">
-              <a:buNone/>
-              <a:defRPr sz="1200"/>
+            <a:lvl8pPr marL="3456432" indent="0">
+              <a:buNone/>
+              <a:defRPr sz="1080"/>
             </a:lvl8pPr>
-            <a:lvl9pPr marL="4389120" indent="0">
-              <a:buNone/>
-              <a:defRPr sz="1200"/>
+            <a:lvl9pPr marL="3950208" indent="0">
+              <a:buNone/>
+              <a:defRPr sz="1080"/>
             </a:lvl9pPr>
           </a:lstStyle>
           <a:p>
@@ -2353,7 +2353,7 @@
           <a:p>
             <a:fld id="{CFC60B5F-2253-DF41-8690-61B53F1555CE}" type="datetimeFigureOut">
               <a:rPr lang="en-US" smtClean="0"/>
-              <a:t>6/18/24</a:t>
+              <a:t>7/1/24</a:t>
             </a:fld>
             <a:endParaRPr lang="en-US"/>
           </a:p>
@@ -2404,7 +2404,7 @@
     </p:spTree>
     <p:extLst>
       <p:ext uri="{BB962C8B-B14F-4D97-AF65-F5344CB8AC3E}">
-        <p14:creationId xmlns:p14="http://schemas.microsoft.com/office/powerpoint/2010/main" val="1694418784"/>
+        <p14:creationId xmlns:p14="http://schemas.microsoft.com/office/powerpoint/2010/main" val="392897067"/>
       </p:ext>
     </p:extLst>
   </p:cSld>
@@ -2448,8 +2448,8 @@
         </p:nvSpPr>
         <p:spPr>
           <a:xfrm>
-            <a:off x="797163" y="438152"/>
-            <a:ext cx="10000774" cy="1590676"/>
+            <a:off x="678964" y="438152"/>
+            <a:ext cx="8517910" cy="1590676"/>
           </a:xfrm>
           <a:prstGeom prst="rect">
             <a:avLst/>
@@ -2481,8 +2481,8 @@
         </p:nvSpPr>
         <p:spPr>
           <a:xfrm>
-            <a:off x="797163" y="2190750"/>
-            <a:ext cx="10000774" cy="5221606"/>
+            <a:off x="678964" y="2190750"/>
+            <a:ext cx="8517910" cy="5221606"/>
           </a:xfrm>
           <a:prstGeom prst="rect">
             <a:avLst/>
@@ -2543,8 +2543,8 @@
         </p:nvSpPr>
         <p:spPr>
           <a:xfrm>
-            <a:off x="797163" y="7627622"/>
-            <a:ext cx="2608898" cy="438150"/>
+            <a:off x="678964" y="7627622"/>
+            <a:ext cx="2222064" cy="438150"/>
           </a:xfrm>
           <a:prstGeom prst="rect">
             <a:avLst/>
@@ -2554,7 +2554,7 @@
           <a:bodyPr vert="horz" lIns="91440" tIns="45720" rIns="91440" bIns="45720" rtlCol="0" anchor="ctr"/>
           <a:lstStyle>
             <a:lvl1pPr algn="l">
-              <a:defRPr sz="1440">
+              <a:defRPr sz="1296">
                 <a:solidFill>
                   <a:schemeClr val="tx1">
                     <a:tint val="75000"/>
@@ -2566,7 +2566,7 @@
           <a:p>
             <a:fld id="{CFC60B5F-2253-DF41-8690-61B53F1555CE}" type="datetimeFigureOut">
               <a:rPr lang="en-US" smtClean="0"/>
-              <a:t>6/18/24</a:t>
+              <a:t>7/1/24</a:t>
             </a:fld>
             <a:endParaRPr lang="en-US"/>
           </a:p>
@@ -2584,8 +2584,8 @@
         </p:nvSpPr>
         <p:spPr>
           <a:xfrm>
-            <a:off x="3840877" y="7627622"/>
-            <a:ext cx="3913346" cy="438150"/>
+            <a:off x="3271372" y="7627622"/>
+            <a:ext cx="3333095" cy="438150"/>
           </a:xfrm>
           <a:prstGeom prst="rect">
             <a:avLst/>
@@ -2595,7 +2595,7 @@
           <a:bodyPr vert="horz" lIns="91440" tIns="45720" rIns="91440" bIns="45720" rtlCol="0" anchor="ctr"/>
           <a:lstStyle>
             <a:lvl1pPr algn="ctr">
-              <a:defRPr sz="1440">
+              <a:defRPr sz="1296">
                 <a:solidFill>
                   <a:schemeClr val="tx1">
                     <a:tint val="75000"/>
@@ -2621,8 +2621,8 @@
         </p:nvSpPr>
         <p:spPr>
           <a:xfrm>
-            <a:off x="8189039" y="7627622"/>
-            <a:ext cx="2608898" cy="438150"/>
+            <a:off x="6974810" y="7627622"/>
+            <a:ext cx="2222064" cy="438150"/>
           </a:xfrm>
           <a:prstGeom prst="rect">
             <a:avLst/>
@@ -2632,7 +2632,7 @@
           <a:bodyPr vert="horz" lIns="91440" tIns="45720" rIns="91440" bIns="45720" rtlCol="0" anchor="ctr"/>
           <a:lstStyle>
             <a:lvl1pPr algn="r">
-              <a:defRPr sz="1440">
+              <a:defRPr sz="1296">
                 <a:solidFill>
                   <a:schemeClr val="tx1">
                     <a:tint val="75000"/>
@@ -2653,27 +2653,27 @@
     </p:spTree>
     <p:extLst>
       <p:ext uri="{BB962C8B-B14F-4D97-AF65-F5344CB8AC3E}">
-        <p14:creationId xmlns:p14="http://schemas.microsoft.com/office/powerpoint/2010/main" val="1783447056"/>
+        <p14:creationId xmlns:p14="http://schemas.microsoft.com/office/powerpoint/2010/main" val="2087634082"/>
       </p:ext>
     </p:extLst>
   </p:cSld>
   <p:clrMap bg1="lt1" tx1="dk1" bg2="lt2" tx2="dk2" accent1="accent1" accent2="accent2" accent3="accent3" accent4="accent4" accent5="accent5" accent6="accent6" hlink="hlink" folHlink="folHlink"/>
   <p:sldLayoutIdLst>
-    <p:sldLayoutId id="2147483877" r:id="rId1"/>
-    <p:sldLayoutId id="2147483878" r:id="rId2"/>
-    <p:sldLayoutId id="2147483879" r:id="rId3"/>
-    <p:sldLayoutId id="2147483880" r:id="rId4"/>
-    <p:sldLayoutId id="2147483881" r:id="rId5"/>
-    <p:sldLayoutId id="2147483882" r:id="rId6"/>
-    <p:sldLayoutId id="2147483883" r:id="rId7"/>
-    <p:sldLayoutId id="2147483884" r:id="rId8"/>
-    <p:sldLayoutId id="2147483885" r:id="rId9"/>
-    <p:sldLayoutId id="2147483886" r:id="rId10"/>
-    <p:sldLayoutId id="2147483887" r:id="rId11"/>
+    <p:sldLayoutId id="2147483889" r:id="rId1"/>
+    <p:sldLayoutId id="2147483890" r:id="rId2"/>
+    <p:sldLayoutId id="2147483891" r:id="rId3"/>
+    <p:sldLayoutId id="2147483892" r:id="rId4"/>
+    <p:sldLayoutId id="2147483893" r:id="rId5"/>
+    <p:sldLayoutId id="2147483894" r:id="rId6"/>
+    <p:sldLayoutId id="2147483895" r:id="rId7"/>
+    <p:sldLayoutId id="2147483896" r:id="rId8"/>
+    <p:sldLayoutId id="2147483897" r:id="rId9"/>
+    <p:sldLayoutId id="2147483898" r:id="rId10"/>
+    <p:sldLayoutId id="2147483899" r:id="rId11"/>
   </p:sldLayoutIdLst>
   <p:txStyles>
     <p:titleStyle>
-      <a:lvl1pPr algn="l" defTabSz="1097280" rtl="0" eaLnBrk="1" latinLnBrk="0" hangingPunct="1">
+      <a:lvl1pPr algn="l" defTabSz="987552" rtl="0" eaLnBrk="1" latinLnBrk="0" hangingPunct="1">
         <a:lnSpc>
           <a:spcPct val="90000"/>
         </a:lnSpc>
@@ -2681,7 +2681,7 @@
           <a:spcPct val="0"/>
         </a:spcBef>
         <a:buNone/>
-        <a:defRPr sz="5280" kern="1200">
+        <a:defRPr sz="4752" kern="1200">
           <a:solidFill>
             <a:schemeClr val="tx1"/>
           </a:solidFill>
@@ -2692,16 +2692,16 @@
       </a:lvl1pPr>
     </p:titleStyle>
     <p:bodyStyle>
-      <a:lvl1pPr marL="274320" indent="-274320" algn="l" defTabSz="1097280" rtl="0" eaLnBrk="1" latinLnBrk="0" hangingPunct="1">
+      <a:lvl1pPr marL="246888" indent="-246888" algn="l" defTabSz="987552" rtl="0" eaLnBrk="1" latinLnBrk="0" hangingPunct="1">
         <a:lnSpc>
           <a:spcPct val="90000"/>
         </a:lnSpc>
         <a:spcBef>
-          <a:spcPts val="1200"/>
+          <a:spcPts val="1080"/>
         </a:spcBef>
         <a:buFont typeface="Arial" panose="020B0604020202020204" pitchFamily="34" charset="0"/>
         <a:buChar char="•"/>
-        <a:defRPr sz="3360" kern="1200">
+        <a:defRPr sz="3024" kern="1200">
           <a:solidFill>
             <a:schemeClr val="tx1"/>
           </a:solidFill>
@@ -2710,16 +2710,16 @@
           <a:cs typeface="+mn-cs"/>
         </a:defRPr>
       </a:lvl1pPr>
-      <a:lvl2pPr marL="822960" indent="-274320" algn="l" defTabSz="1097280" rtl="0" eaLnBrk="1" latinLnBrk="0" hangingPunct="1">
+      <a:lvl2pPr marL="740664" indent="-246888" algn="l" defTabSz="987552" rtl="0" eaLnBrk="1" latinLnBrk="0" hangingPunct="1">
         <a:lnSpc>
           <a:spcPct val="90000"/>
         </a:lnSpc>
         <a:spcBef>
-          <a:spcPts val="600"/>
+          <a:spcPts val="540"/>
         </a:spcBef>
         <a:buFont typeface="Arial" panose="020B0604020202020204" pitchFamily="34" charset="0"/>
         <a:buChar char="•"/>
-        <a:defRPr sz="2880" kern="1200">
+        <a:defRPr sz="2592" kern="1200">
           <a:solidFill>
             <a:schemeClr val="tx1"/>
           </a:solidFill>
@@ -2728,30 +2728,12 @@
           <a:cs typeface="+mn-cs"/>
         </a:defRPr>
       </a:lvl2pPr>
-      <a:lvl3pPr marL="1371600" indent="-274320" algn="l" defTabSz="1097280" rtl="0" eaLnBrk="1" latinLnBrk="0" hangingPunct="1">
+      <a:lvl3pPr marL="1234440" indent="-246888" algn="l" defTabSz="987552" rtl="0" eaLnBrk="1" latinLnBrk="0" hangingPunct="1">
         <a:lnSpc>
           <a:spcPct val="90000"/>
         </a:lnSpc>
         <a:spcBef>
-          <a:spcPts val="600"/>
-        </a:spcBef>
-        <a:buFont typeface="Arial" panose="020B0604020202020204" pitchFamily="34" charset="0"/>
-        <a:buChar char="•"/>
-        <a:defRPr sz="2400" kern="1200">
-          <a:solidFill>
-            <a:schemeClr val="tx1"/>
-          </a:solidFill>
-          <a:latin typeface="+mn-lt"/>
-          <a:ea typeface="+mn-ea"/>
-          <a:cs typeface="+mn-cs"/>
-        </a:defRPr>
-      </a:lvl3pPr>
-      <a:lvl4pPr marL="1920240" indent="-274320" algn="l" defTabSz="1097280" rtl="0" eaLnBrk="1" latinLnBrk="0" hangingPunct="1">
-        <a:lnSpc>
-          <a:spcPct val="90000"/>
-        </a:lnSpc>
-        <a:spcBef>
-          <a:spcPts val="600"/>
+          <a:spcPts val="540"/>
         </a:spcBef>
         <a:buFont typeface="Arial" panose="020B0604020202020204" pitchFamily="34" charset="0"/>
         <a:buChar char="•"/>
@@ -2763,17 +2745,35 @@
           <a:ea typeface="+mn-ea"/>
           <a:cs typeface="+mn-cs"/>
         </a:defRPr>
-      </a:lvl4pPr>
-      <a:lvl5pPr marL="2468880" indent="-274320" algn="l" defTabSz="1097280" rtl="0" eaLnBrk="1" latinLnBrk="0" hangingPunct="1">
+      </a:lvl3pPr>
+      <a:lvl4pPr marL="1728216" indent="-246888" algn="l" defTabSz="987552" rtl="0" eaLnBrk="1" latinLnBrk="0" hangingPunct="1">
         <a:lnSpc>
           <a:spcPct val="90000"/>
         </a:lnSpc>
         <a:spcBef>
-          <a:spcPts val="600"/>
+          <a:spcPts val="540"/>
         </a:spcBef>
         <a:buFont typeface="Arial" panose="020B0604020202020204" pitchFamily="34" charset="0"/>
         <a:buChar char="•"/>
-        <a:defRPr sz="2160" kern="1200">
+        <a:defRPr sz="1944" kern="1200">
+          <a:solidFill>
+            <a:schemeClr val="tx1"/>
+          </a:solidFill>
+          <a:latin typeface="+mn-lt"/>
+          <a:ea typeface="+mn-ea"/>
+          <a:cs typeface="+mn-cs"/>
+        </a:defRPr>
+      </a:lvl4pPr>
+      <a:lvl5pPr marL="2221992" indent="-246888" algn="l" defTabSz="987552" rtl="0" eaLnBrk="1" latinLnBrk="0" hangingPunct="1">
+        <a:lnSpc>
+          <a:spcPct val="90000"/>
+        </a:lnSpc>
+        <a:spcBef>
+          <a:spcPts val="540"/>
+        </a:spcBef>
+        <a:buFont typeface="Arial" panose="020B0604020202020204" pitchFamily="34" charset="0"/>
+        <a:buChar char="•"/>
+        <a:defRPr sz="1944" kern="1200">
           <a:solidFill>
             <a:schemeClr val="tx1"/>
           </a:solidFill>
@@ -2782,16 +2782,16 @@
           <a:cs typeface="+mn-cs"/>
         </a:defRPr>
       </a:lvl5pPr>
-      <a:lvl6pPr marL="3017520" indent="-274320" algn="l" defTabSz="1097280" rtl="0" eaLnBrk="1" latinLnBrk="0" hangingPunct="1">
+      <a:lvl6pPr marL="2715768" indent="-246888" algn="l" defTabSz="987552" rtl="0" eaLnBrk="1" latinLnBrk="0" hangingPunct="1">
         <a:lnSpc>
           <a:spcPct val="90000"/>
         </a:lnSpc>
         <a:spcBef>
-          <a:spcPts val="600"/>
+          <a:spcPts val="540"/>
         </a:spcBef>
         <a:buFont typeface="Arial" panose="020B0604020202020204" pitchFamily="34" charset="0"/>
         <a:buChar char="•"/>
-        <a:defRPr sz="2160" kern="1200">
+        <a:defRPr sz="1944" kern="1200">
           <a:solidFill>
             <a:schemeClr val="tx1"/>
           </a:solidFill>
@@ -2800,16 +2800,16 @@
           <a:cs typeface="+mn-cs"/>
         </a:defRPr>
       </a:lvl6pPr>
-      <a:lvl7pPr marL="3566160" indent="-274320" algn="l" defTabSz="1097280" rtl="0" eaLnBrk="1" latinLnBrk="0" hangingPunct="1">
+      <a:lvl7pPr marL="3209544" indent="-246888" algn="l" defTabSz="987552" rtl="0" eaLnBrk="1" latinLnBrk="0" hangingPunct="1">
         <a:lnSpc>
           <a:spcPct val="90000"/>
         </a:lnSpc>
         <a:spcBef>
-          <a:spcPts val="600"/>
+          <a:spcPts val="540"/>
         </a:spcBef>
         <a:buFont typeface="Arial" panose="020B0604020202020204" pitchFamily="34" charset="0"/>
         <a:buChar char="•"/>
-        <a:defRPr sz="2160" kern="1200">
+        <a:defRPr sz="1944" kern="1200">
           <a:solidFill>
             <a:schemeClr val="tx1"/>
           </a:solidFill>
@@ -2818,16 +2818,16 @@
           <a:cs typeface="+mn-cs"/>
         </a:defRPr>
       </a:lvl7pPr>
-      <a:lvl8pPr marL="4114800" indent="-274320" algn="l" defTabSz="1097280" rtl="0" eaLnBrk="1" latinLnBrk="0" hangingPunct="1">
+      <a:lvl8pPr marL="3703320" indent="-246888" algn="l" defTabSz="987552" rtl="0" eaLnBrk="1" latinLnBrk="0" hangingPunct="1">
         <a:lnSpc>
           <a:spcPct val="90000"/>
         </a:lnSpc>
         <a:spcBef>
-          <a:spcPts val="600"/>
+          <a:spcPts val="540"/>
         </a:spcBef>
         <a:buFont typeface="Arial" panose="020B0604020202020204" pitchFamily="34" charset="0"/>
         <a:buChar char="•"/>
-        <a:defRPr sz="2160" kern="1200">
+        <a:defRPr sz="1944" kern="1200">
           <a:solidFill>
             <a:schemeClr val="tx1"/>
           </a:solidFill>
@@ -2836,16 +2836,16 @@
           <a:cs typeface="+mn-cs"/>
         </a:defRPr>
       </a:lvl8pPr>
-      <a:lvl9pPr marL="4663440" indent="-274320" algn="l" defTabSz="1097280" rtl="0" eaLnBrk="1" latinLnBrk="0" hangingPunct="1">
+      <a:lvl9pPr marL="4197096" indent="-246888" algn="l" defTabSz="987552" rtl="0" eaLnBrk="1" latinLnBrk="0" hangingPunct="1">
         <a:lnSpc>
           <a:spcPct val="90000"/>
         </a:lnSpc>
         <a:spcBef>
-          <a:spcPts val="600"/>
+          <a:spcPts val="540"/>
         </a:spcBef>
         <a:buFont typeface="Arial" panose="020B0604020202020204" pitchFamily="34" charset="0"/>
         <a:buChar char="•"/>
-        <a:defRPr sz="2160" kern="1200">
+        <a:defRPr sz="1944" kern="1200">
           <a:solidFill>
             <a:schemeClr val="tx1"/>
           </a:solidFill>
@@ -2859,8 +2859,8 @@
       <a:defPPr>
         <a:defRPr lang="en-US"/>
       </a:defPPr>
-      <a:lvl1pPr marL="0" algn="l" defTabSz="1097280" rtl="0" eaLnBrk="1" latinLnBrk="0" hangingPunct="1">
-        <a:defRPr sz="2160" kern="1200">
+      <a:lvl1pPr marL="0" algn="l" defTabSz="987552" rtl="0" eaLnBrk="1" latinLnBrk="0" hangingPunct="1">
+        <a:defRPr sz="1944" kern="1200">
           <a:solidFill>
             <a:schemeClr val="tx1"/>
           </a:solidFill>
@@ -2869,8 +2869,8 @@
           <a:cs typeface="+mn-cs"/>
         </a:defRPr>
       </a:lvl1pPr>
-      <a:lvl2pPr marL="548640" algn="l" defTabSz="1097280" rtl="0" eaLnBrk="1" latinLnBrk="0" hangingPunct="1">
-        <a:defRPr sz="2160" kern="1200">
+      <a:lvl2pPr marL="493776" algn="l" defTabSz="987552" rtl="0" eaLnBrk="1" latinLnBrk="0" hangingPunct="1">
+        <a:defRPr sz="1944" kern="1200">
           <a:solidFill>
             <a:schemeClr val="tx1"/>
           </a:solidFill>
@@ -2879,8 +2879,8 @@
           <a:cs typeface="+mn-cs"/>
         </a:defRPr>
       </a:lvl2pPr>
-      <a:lvl3pPr marL="1097280" algn="l" defTabSz="1097280" rtl="0" eaLnBrk="1" latinLnBrk="0" hangingPunct="1">
-        <a:defRPr sz="2160" kern="1200">
+      <a:lvl3pPr marL="987552" algn="l" defTabSz="987552" rtl="0" eaLnBrk="1" latinLnBrk="0" hangingPunct="1">
+        <a:defRPr sz="1944" kern="1200">
           <a:solidFill>
             <a:schemeClr val="tx1"/>
           </a:solidFill>
@@ -2889,8 +2889,8 @@
           <a:cs typeface="+mn-cs"/>
         </a:defRPr>
       </a:lvl3pPr>
-      <a:lvl4pPr marL="1645920" algn="l" defTabSz="1097280" rtl="0" eaLnBrk="1" latinLnBrk="0" hangingPunct="1">
-        <a:defRPr sz="2160" kern="1200">
+      <a:lvl4pPr marL="1481328" algn="l" defTabSz="987552" rtl="0" eaLnBrk="1" latinLnBrk="0" hangingPunct="1">
+        <a:defRPr sz="1944" kern="1200">
           <a:solidFill>
             <a:schemeClr val="tx1"/>
           </a:solidFill>
@@ -2899,8 +2899,8 @@
           <a:cs typeface="+mn-cs"/>
         </a:defRPr>
       </a:lvl4pPr>
-      <a:lvl5pPr marL="2194560" algn="l" defTabSz="1097280" rtl="0" eaLnBrk="1" latinLnBrk="0" hangingPunct="1">
-        <a:defRPr sz="2160" kern="1200">
+      <a:lvl5pPr marL="1975104" algn="l" defTabSz="987552" rtl="0" eaLnBrk="1" latinLnBrk="0" hangingPunct="1">
+        <a:defRPr sz="1944" kern="1200">
           <a:solidFill>
             <a:schemeClr val="tx1"/>
           </a:solidFill>
@@ -2909,8 +2909,8 @@
           <a:cs typeface="+mn-cs"/>
         </a:defRPr>
       </a:lvl5pPr>
-      <a:lvl6pPr marL="2743200" algn="l" defTabSz="1097280" rtl="0" eaLnBrk="1" latinLnBrk="0" hangingPunct="1">
-        <a:defRPr sz="2160" kern="1200">
+      <a:lvl6pPr marL="2468880" algn="l" defTabSz="987552" rtl="0" eaLnBrk="1" latinLnBrk="0" hangingPunct="1">
+        <a:defRPr sz="1944" kern="1200">
           <a:solidFill>
             <a:schemeClr val="tx1"/>
           </a:solidFill>
@@ -2919,8 +2919,8 @@
           <a:cs typeface="+mn-cs"/>
         </a:defRPr>
       </a:lvl6pPr>
-      <a:lvl7pPr marL="3291840" algn="l" defTabSz="1097280" rtl="0" eaLnBrk="1" latinLnBrk="0" hangingPunct="1">
-        <a:defRPr sz="2160" kern="1200">
+      <a:lvl7pPr marL="2962656" algn="l" defTabSz="987552" rtl="0" eaLnBrk="1" latinLnBrk="0" hangingPunct="1">
+        <a:defRPr sz="1944" kern="1200">
           <a:solidFill>
             <a:schemeClr val="tx1"/>
           </a:solidFill>
@@ -2929,8 +2929,8 @@
           <a:cs typeface="+mn-cs"/>
         </a:defRPr>
       </a:lvl7pPr>
-      <a:lvl8pPr marL="3840480" algn="l" defTabSz="1097280" rtl="0" eaLnBrk="1" latinLnBrk="0" hangingPunct="1">
-        <a:defRPr sz="2160" kern="1200">
+      <a:lvl8pPr marL="3456432" algn="l" defTabSz="987552" rtl="0" eaLnBrk="1" latinLnBrk="0" hangingPunct="1">
+        <a:defRPr sz="1944" kern="1200">
           <a:solidFill>
             <a:schemeClr val="tx1"/>
           </a:solidFill>
@@ -2939,8 +2939,8 @@
           <a:cs typeface="+mn-cs"/>
         </a:defRPr>
       </a:lvl8pPr>
-      <a:lvl9pPr marL="4389120" algn="l" defTabSz="1097280" rtl="0" eaLnBrk="1" latinLnBrk="0" hangingPunct="1">
-        <a:defRPr sz="2160" kern="1200">
+      <a:lvl9pPr marL="3950208" algn="l" defTabSz="987552" rtl="0" eaLnBrk="1" latinLnBrk="0" hangingPunct="1">
+        <a:defRPr sz="1944" kern="1200">
           <a:solidFill>
             <a:schemeClr val="tx1"/>
           </a:solidFill>
@@ -2971,136 +2971,12 @@
           <a:chExt cx="0" cy="0"/>
         </a:xfrm>
       </p:grpSpPr>
-      <p:sp>
-        <p:nvSpPr>
-          <p:cNvPr id="8" name="TextBox 7">
+      <p:pic>
+        <p:nvPicPr>
+          <p:cNvPr id="5" name="Picture 4">
             <a:extLst>
               <a:ext uri="{FF2B5EF4-FFF2-40B4-BE49-F238E27FC236}">
-                <a16:creationId xmlns:a16="http://schemas.microsoft.com/office/drawing/2014/main" id="{F29E1621-45F5-0E44-8AE7-A27A3F167BBB}"/>
-              </a:ext>
-            </a:extLst>
-          </p:cNvPr>
-          <p:cNvSpPr txBox="1"/>
-          <p:nvPr/>
-        </p:nvSpPr>
-        <p:spPr>
-          <a:xfrm rot="16200000">
-            <a:off x="-1612446" y="1559440"/>
-            <a:ext cx="3580544" cy="461665"/>
-          </a:xfrm>
-          <a:prstGeom prst="rect">
-            <a:avLst/>
-          </a:prstGeom>
-          <a:noFill/>
-        </p:spPr>
-        <p:txBody>
-          <a:bodyPr wrap="square" rtlCol="0">
-            <a:spAutoFit/>
-          </a:bodyPr>
-          <a:lstStyle/>
-          <a:p>
-            <a:pPr algn="ctr"/>
-            <a:r>
-              <a:rPr lang="en-US" sz="2400" b="1" u="sng" dirty="0"/>
-              <a:t>Exploratory</a:t>
-            </a:r>
-          </a:p>
-        </p:txBody>
-      </p:sp>
-      <p:sp>
-        <p:nvSpPr>
-          <p:cNvPr id="9" name="TextBox 8">
-            <a:extLst>
-              <a:ext uri="{FF2B5EF4-FFF2-40B4-BE49-F238E27FC236}">
-                <a16:creationId xmlns:a16="http://schemas.microsoft.com/office/drawing/2014/main" id="{AFFD002C-597E-27AE-5BF2-45F12AD9ABE3}"/>
-              </a:ext>
-            </a:extLst>
-          </p:cNvPr>
-          <p:cNvSpPr txBox="1"/>
-          <p:nvPr/>
-        </p:nvSpPr>
-        <p:spPr>
-          <a:xfrm rot="16200000">
-            <a:off x="-1613181" y="5674150"/>
-            <a:ext cx="3580544" cy="461665"/>
-          </a:xfrm>
-          <a:prstGeom prst="rect">
-            <a:avLst/>
-          </a:prstGeom>
-          <a:noFill/>
-        </p:spPr>
-        <p:txBody>
-          <a:bodyPr wrap="square" rtlCol="0">
-            <a:spAutoFit/>
-          </a:bodyPr>
-          <a:lstStyle/>
-          <a:p>
-            <a:pPr algn="ctr"/>
-            <a:r>
-              <a:rPr lang="en-US" sz="2400" b="1" u="sng" dirty="0"/>
-              <a:t>Confirmatory</a:t>
-            </a:r>
-          </a:p>
-        </p:txBody>
-      </p:sp>
-      <p:sp>
-        <p:nvSpPr>
-          <p:cNvPr id="2" name="Rectangle 1">
-            <a:extLst>
-              <a:ext uri="{FF2B5EF4-FFF2-40B4-BE49-F238E27FC236}">
-                <a16:creationId xmlns:a16="http://schemas.microsoft.com/office/drawing/2014/main" id="{351A6723-6A9F-7741-C396-05C2116A8F26}"/>
-              </a:ext>
-            </a:extLst>
-          </p:cNvPr>
-          <p:cNvSpPr/>
-          <p:nvPr/>
-        </p:nvSpPr>
-        <p:spPr>
-          <a:xfrm>
-            <a:off x="246344" y="4649057"/>
-            <a:ext cx="998806" cy="407963"/>
-          </a:xfrm>
-          <a:prstGeom prst="rect">
-            <a:avLst/>
-          </a:prstGeom>
-          <a:solidFill>
-            <a:schemeClr val="bg1"/>
-          </a:solidFill>
-          <a:ln>
-            <a:noFill/>
-          </a:ln>
-        </p:spPr>
-        <p:style>
-          <a:lnRef idx="2">
-            <a:schemeClr val="accent1">
-              <a:shade val="15000"/>
-            </a:schemeClr>
-          </a:lnRef>
-          <a:fillRef idx="1">
-            <a:schemeClr val="accent1"/>
-          </a:fillRef>
-          <a:effectRef idx="0">
-            <a:schemeClr val="accent1"/>
-          </a:effectRef>
-          <a:fontRef idx="minor">
-            <a:schemeClr val="lt1"/>
-          </a:fontRef>
-        </p:style>
-        <p:txBody>
-          <a:bodyPr rtlCol="0" anchor="ctr"/>
-          <a:lstStyle/>
-          <a:p>
-            <a:pPr algn="ctr"/>
-            <a:endParaRPr lang="en-US"/>
-          </a:p>
-        </p:txBody>
-      </p:sp>
-      <p:pic>
-        <p:nvPicPr>
-          <p:cNvPr id="4" name="Picture 3">
-            <a:extLst>
-              <a:ext uri="{FF2B5EF4-FFF2-40B4-BE49-F238E27FC236}">
-                <a16:creationId xmlns:a16="http://schemas.microsoft.com/office/drawing/2014/main" id="{9FAF7616-FCFD-9965-028F-427960EF4390}"/>
+                <a16:creationId xmlns:a16="http://schemas.microsoft.com/office/drawing/2014/main" id="{15AEC54E-E6D2-B114-5C4C-8AA25E3F2B4A}"/>
               </a:ext>
             </a:extLst>
           </p:cNvPr>
@@ -3117,8 +2993,8 @@
         </p:blipFill>
         <p:spPr>
           <a:xfrm>
-            <a:off x="460933" y="-44"/>
-            <a:ext cx="11134167" cy="4114800"/>
+            <a:off x="470580" y="-90"/>
+            <a:ext cx="9405257" cy="4114800"/>
           </a:xfrm>
           <a:prstGeom prst="rect">
             <a:avLst/>
@@ -3127,10 +3003,10 @@
       </p:pic>
       <p:pic>
         <p:nvPicPr>
-          <p:cNvPr id="6" name="Picture 5">
+          <p:cNvPr id="12" name="Picture 11">
             <a:extLst>
               <a:ext uri="{FF2B5EF4-FFF2-40B4-BE49-F238E27FC236}">
-                <a16:creationId xmlns:a16="http://schemas.microsoft.com/office/drawing/2014/main" id="{390030FC-DD33-DC2F-5AD3-F14BF41310D0}"/>
+                <a16:creationId xmlns:a16="http://schemas.microsoft.com/office/drawing/2014/main" id="{BE62FA59-25B6-2EA2-1BB2-275EE0563890}"/>
               </a:ext>
             </a:extLst>
           </p:cNvPr>
@@ -3147,8 +3023,8 @@
         </p:blipFill>
         <p:spPr>
           <a:xfrm>
-            <a:off x="460932" y="4114756"/>
-            <a:ext cx="11134167" cy="4114800"/>
+            <a:off x="470581" y="4114800"/>
+            <a:ext cx="9405257" cy="4114800"/>
           </a:xfrm>
           <a:prstGeom prst="rect">
             <a:avLst/>
@@ -3157,10 +3033,82 @@
       </p:pic>
       <p:sp>
         <p:nvSpPr>
-          <p:cNvPr id="7" name="Rectangle 6">
+          <p:cNvPr id="8" name="TextBox 7">
             <a:extLst>
               <a:ext uri="{FF2B5EF4-FFF2-40B4-BE49-F238E27FC236}">
-                <a16:creationId xmlns:a16="http://schemas.microsoft.com/office/drawing/2014/main" id="{C0C28FEC-96DB-E897-A125-CF7EB27CFB20}"/>
+                <a16:creationId xmlns:a16="http://schemas.microsoft.com/office/drawing/2014/main" id="{F29E1621-45F5-0E44-8AE7-A27A3F167BBB}"/>
+              </a:ext>
+            </a:extLst>
+          </p:cNvPr>
+          <p:cNvSpPr txBox="1"/>
+          <p:nvPr/>
+        </p:nvSpPr>
+        <p:spPr>
+          <a:xfrm rot="16200000">
+            <a:off x="-1611218" y="1611219"/>
+            <a:ext cx="3684104" cy="461665"/>
+          </a:xfrm>
+          <a:prstGeom prst="rect">
+            <a:avLst/>
+          </a:prstGeom>
+          <a:noFill/>
+        </p:spPr>
+        <p:txBody>
+          <a:bodyPr wrap="square" rtlCol="0">
+            <a:spAutoFit/>
+          </a:bodyPr>
+          <a:lstStyle/>
+          <a:p>
+            <a:pPr algn="ctr"/>
+            <a:r>
+              <a:rPr lang="en-US" sz="2400" b="1" u="sng" dirty="0"/>
+              <a:t>Exploratory</a:t>
+            </a:r>
+          </a:p>
+        </p:txBody>
+      </p:sp>
+      <p:sp>
+        <p:nvSpPr>
+          <p:cNvPr id="9" name="TextBox 8">
+            <a:extLst>
+              <a:ext uri="{FF2B5EF4-FFF2-40B4-BE49-F238E27FC236}">
+                <a16:creationId xmlns:a16="http://schemas.microsoft.com/office/drawing/2014/main" id="{AFFD002C-597E-27AE-5BF2-45F12AD9ABE3}"/>
+              </a:ext>
+            </a:extLst>
+          </p:cNvPr>
+          <p:cNvSpPr txBox="1"/>
+          <p:nvPr/>
+        </p:nvSpPr>
+        <p:spPr>
+          <a:xfrm rot="16200000">
+            <a:off x="-1602304" y="5725931"/>
+            <a:ext cx="3684107" cy="461665"/>
+          </a:xfrm>
+          <a:prstGeom prst="rect">
+            <a:avLst/>
+          </a:prstGeom>
+          <a:noFill/>
+        </p:spPr>
+        <p:txBody>
+          <a:bodyPr wrap="square" rtlCol="0">
+            <a:spAutoFit/>
+          </a:bodyPr>
+          <a:lstStyle/>
+          <a:p>
+            <a:pPr algn="ctr"/>
+            <a:r>
+              <a:rPr lang="en-US" sz="2400" b="1" u="sng" dirty="0"/>
+              <a:t>Confirmatory</a:t>
+            </a:r>
+          </a:p>
+        </p:txBody>
+      </p:sp>
+      <p:sp>
+        <p:nvSpPr>
+          <p:cNvPr id="10" name="Rectangle 9">
+            <a:extLst>
+              <a:ext uri="{FF2B5EF4-FFF2-40B4-BE49-F238E27FC236}">
+                <a16:creationId xmlns:a16="http://schemas.microsoft.com/office/drawing/2014/main" id="{6DF70099-8625-C289-F0DE-8539D10A67AE}"/>
               </a:ext>
             </a:extLst>
           </p:cNvPr>
@@ -3169,8 +3117,8 @@
         </p:nvSpPr>
         <p:spPr>
           <a:xfrm>
-            <a:off x="6866313" y="4384964"/>
-            <a:ext cx="1080654" cy="128847"/>
+            <a:off x="8049276" y="-181"/>
+            <a:ext cx="1826561" cy="8229781"/>
           </a:xfrm>
           <a:prstGeom prst="rect">
             <a:avLst/>
@@ -3209,60 +3157,35 @@
           </a:p>
         </p:txBody>
       </p:sp>
-      <p:sp>
-        <p:nvSpPr>
-          <p:cNvPr id="10" name="Rectangle 9">
+      <p:pic>
+        <p:nvPicPr>
+          <p:cNvPr id="13" name="Picture 12">
             <a:extLst>
               <a:ext uri="{FF2B5EF4-FFF2-40B4-BE49-F238E27FC236}">
-                <a16:creationId xmlns:a16="http://schemas.microsoft.com/office/drawing/2014/main" id="{6DF70099-8625-C289-F0DE-8539D10A67AE}"/>
+                <a16:creationId xmlns:a16="http://schemas.microsoft.com/office/drawing/2014/main" id="{AF507551-7F9D-29F2-6CCF-F5A32560769C}"/>
               </a:ext>
             </a:extLst>
           </p:cNvPr>
-          <p:cNvSpPr/>
+          <p:cNvPicPr>
+            <a:picLocks noChangeAspect="1"/>
+          </p:cNvPicPr>
           <p:nvPr/>
-        </p:nvSpPr>
+        </p:nvPicPr>
+        <p:blipFill rotWithShape="1">
+          <a:blip r:embed="rId4"/>
+          <a:srcRect l="80158"/>
+          <a:stretch/>
+        </p:blipFill>
         <p:spPr>
           <a:xfrm>
-            <a:off x="6866313" y="4513811"/>
-            <a:ext cx="415636" cy="910244"/>
+            <a:off x="8009623" y="2057400"/>
+            <a:ext cx="1866214" cy="4114800"/>
           </a:xfrm>
           <a:prstGeom prst="rect">
             <a:avLst/>
           </a:prstGeom>
-          <a:solidFill>
-            <a:schemeClr val="bg1"/>
-          </a:solidFill>
-          <a:ln>
-            <a:solidFill>
-              <a:schemeClr val="bg1"/>
-            </a:solidFill>
-          </a:ln>
         </p:spPr>
-        <p:style>
-          <a:lnRef idx="2">
-            <a:schemeClr val="accent1">
-              <a:shade val="15000"/>
-            </a:schemeClr>
-          </a:lnRef>
-          <a:fillRef idx="1">
-            <a:schemeClr val="accent1"/>
-          </a:fillRef>
-          <a:effectRef idx="0">
-            <a:schemeClr val="accent1"/>
-          </a:effectRef>
-          <a:fontRef idx="minor">
-            <a:schemeClr val="lt1"/>
-          </a:fontRef>
-        </p:style>
-        <p:txBody>
-          <a:bodyPr rtlCol="0" anchor="ctr"/>
-          <a:lstStyle/>
-          <a:p>
-            <a:pPr algn="ctr"/>
-            <a:endParaRPr lang="en-US"/>
-          </a:p>
-        </p:txBody>
-      </p:sp>
+      </p:pic>
     </p:spTree>
     <p:extLst>
       <p:ext uri="{BB962C8B-B14F-4D97-AF65-F5344CB8AC3E}">

</xml_diff>